<commit_message>
Some small further alignments
</commit_message>
<xml_diff>
--- a/public/templates/template.pptx
+++ b/public/templates/template.pptx
@@ -107,12 +107,129 @@
       </a:defRPr>
     </a:lvl9pPr>
   </p:defaultTextStyle>
-  <p:extLst>
-    <p:ext uri="{EFAFB233-063F-42B5-8137-9DF3F51BA10A}">
-      <p15:sldGuideLst xmlns:p15="http://schemas.microsoft.com/office/powerpoint/2012/main"/>
-    </p:ext>
-  </p:extLst>
 </p:presentation>
+</file>
+
+<file path=ppt/revisionInfo.xml><?xml version="1.0" encoding="utf-8"?>
+<p1510:revInfo xmlns:a="http://schemas.openxmlformats.org/drawingml/2006/main" xmlns:r="http://schemas.openxmlformats.org/officeDocument/2006/relationships" xmlns:p1510="http://schemas.microsoft.com/office/powerpoint/2015/10/main">
+  <p1510:revLst>
+    <p1510:client id="{3EDA70AF-CE7E-153D-0352-F0344AE445A7}" v="85" dt="2026-01-06T16:24:22.443"/>
+    <p1510:client id="{C0F3D160-2F89-6D78-2E2F-CA9C0DFDCFC3}" v="2" dt="2026-01-06T16:39:24.956"/>
+  </p1510:revLst>
+</p1510:revInfo>
+</file>
+
+<file path=ppt/changesInfos/changesInfo1.xml><?xml version="1.0" encoding="utf-8"?>
+<pc:chgInfo xmlns:a="http://schemas.openxmlformats.org/drawingml/2006/main" xmlns:r="http://schemas.openxmlformats.org/officeDocument/2006/relationships" xmlns:ac="http://schemas.microsoft.com/office/drawing/2013/main/command" xmlns:pc="http://schemas.microsoft.com/office/powerpoint/2013/main/command">
+  <pc:docChgLst>
+    <pc:chgData name="Moritz Schlager" userId="faf8158ddec16f45" providerId="Windows Live" clId="Web-{C0F3D160-2F89-6D78-2E2F-CA9C0DFDCFC3}"/>
+    <pc:docChg chg="modSld">
+      <pc:chgData name="Moritz Schlager" userId="faf8158ddec16f45" providerId="Windows Live" clId="Web-{C0F3D160-2F89-6D78-2E2F-CA9C0DFDCFC3}" dt="2026-01-06T16:39:24.956" v="1"/>
+      <pc:docMkLst>
+        <pc:docMk/>
+      </pc:docMkLst>
+      <pc:sldChg chg="modSp">
+        <pc:chgData name="Moritz Schlager" userId="faf8158ddec16f45" providerId="Windows Live" clId="Web-{C0F3D160-2F89-6D78-2E2F-CA9C0DFDCFC3}" dt="2026-01-06T16:31:29.269" v="0" actId="20577"/>
+        <pc:sldMkLst>
+          <pc:docMk/>
+          <pc:sldMk cId="3647243530" sldId="283"/>
+        </pc:sldMkLst>
+        <pc:spChg chg="mod">
+          <ac:chgData name="Moritz Schlager" userId="faf8158ddec16f45" providerId="Windows Live" clId="Web-{C0F3D160-2F89-6D78-2E2F-CA9C0DFDCFC3}" dt="2026-01-06T16:31:29.269" v="0" actId="20577"/>
+          <ac:spMkLst>
+            <pc:docMk/>
+            <pc:sldMk cId="3647243530" sldId="283"/>
+            <ac:spMk id="2" creationId="{F00EAF5D-FCB4-3E1E-E472-6379C877B6DF}"/>
+          </ac:spMkLst>
+        </pc:spChg>
+      </pc:sldChg>
+      <pc:sldChg chg="mod modShow">
+        <pc:chgData name="Moritz Schlager" userId="faf8158ddec16f45" providerId="Windows Live" clId="Web-{C0F3D160-2F89-6D78-2E2F-CA9C0DFDCFC3}" dt="2026-01-06T16:39:24.956" v="1"/>
+        <pc:sldMkLst>
+          <pc:docMk/>
+          <pc:sldMk cId="2400761819" sldId="285"/>
+        </pc:sldMkLst>
+      </pc:sldChg>
+    </pc:docChg>
+  </pc:docChgLst>
+  <pc:docChgLst>
+    <pc:chgData name="Moritz Schlager" userId="faf8158ddec16f45" providerId="Windows Live" clId="Web-{3EDA70AF-CE7E-153D-0352-F0344AE445A7}"/>
+    <pc:docChg chg="modSld">
+      <pc:chgData name="Moritz Schlager" userId="faf8158ddec16f45" providerId="Windows Live" clId="Web-{3EDA70AF-CE7E-153D-0352-F0344AE445A7}" dt="2026-01-06T16:24:20.318" v="81" actId="20577"/>
+      <pc:docMkLst>
+        <pc:docMk/>
+      </pc:docMkLst>
+      <pc:sldChg chg="delSp modSp">
+        <pc:chgData name="Moritz Schlager" userId="faf8158ddec16f45" providerId="Windows Live" clId="Web-{3EDA70AF-CE7E-153D-0352-F0344AE445A7}" dt="2026-01-06T16:24:11.084" v="80"/>
+        <pc:sldMkLst>
+          <pc:docMk/>
+          <pc:sldMk cId="1228569147" sldId="260"/>
+        </pc:sldMkLst>
+        <pc:spChg chg="mod">
+          <ac:chgData name="Moritz Schlager" userId="faf8158ddec16f45" providerId="Windows Live" clId="Web-{3EDA70AF-CE7E-153D-0352-F0344AE445A7}" dt="2026-01-06T16:20:45.535" v="2" actId="20577"/>
+          <ac:spMkLst>
+            <pc:docMk/>
+            <pc:sldMk cId="1228569147" sldId="260"/>
+            <ac:spMk id="20" creationId="{E9AD47FE-F18A-325F-B39D-4259E8DB8B48}"/>
+          </ac:spMkLst>
+        </pc:spChg>
+        <pc:picChg chg="del">
+          <ac:chgData name="Moritz Schlager" userId="faf8158ddec16f45" providerId="Windows Live" clId="Web-{3EDA70AF-CE7E-153D-0352-F0344AE445A7}" dt="2026-01-06T16:24:11.084" v="80"/>
+          <ac:picMkLst>
+            <pc:docMk/>
+            <pc:sldMk cId="1228569147" sldId="260"/>
+            <ac:picMk id="1026" creationId="{2212697B-EE35-E0C4-2BC4-4B59A5C82E4A}"/>
+          </ac:picMkLst>
+        </pc:picChg>
+      </pc:sldChg>
+      <pc:sldChg chg="modSp">
+        <pc:chgData name="Moritz Schlager" userId="faf8158ddec16f45" providerId="Windows Live" clId="Web-{3EDA70AF-CE7E-153D-0352-F0344AE445A7}" dt="2026-01-06T16:24:20.318" v="81" actId="20577"/>
+        <pc:sldMkLst>
+          <pc:docMk/>
+          <pc:sldMk cId="3647243530" sldId="283"/>
+        </pc:sldMkLst>
+        <pc:spChg chg="mod">
+          <ac:chgData name="Moritz Schlager" userId="faf8158ddec16f45" providerId="Windows Live" clId="Web-{3EDA70AF-CE7E-153D-0352-F0344AE445A7}" dt="2026-01-06T16:24:20.318" v="81" actId="20577"/>
+          <ac:spMkLst>
+            <pc:docMk/>
+            <pc:sldMk cId="3647243530" sldId="283"/>
+            <ac:spMk id="3" creationId="{627B9912-4325-E623-AD85-4F16C5510121}"/>
+          </ac:spMkLst>
+        </pc:spChg>
+      </pc:sldChg>
+      <pc:sldChg chg="delSp modSp">
+        <pc:chgData name="Moritz Schlager" userId="faf8158ddec16f45" providerId="Windows Live" clId="Web-{3EDA70AF-CE7E-153D-0352-F0344AE445A7}" dt="2026-01-06T16:24:03.240" v="79" actId="14100"/>
+        <pc:sldMkLst>
+          <pc:docMk/>
+          <pc:sldMk cId="2010364610" sldId="284"/>
+        </pc:sldMkLst>
+        <pc:spChg chg="mod">
+          <ac:chgData name="Moritz Schlager" userId="faf8158ddec16f45" providerId="Windows Live" clId="Web-{3EDA70AF-CE7E-153D-0352-F0344AE445A7}" dt="2026-01-06T16:24:03.240" v="79" actId="14100"/>
+          <ac:spMkLst>
+            <pc:docMk/>
+            <pc:sldMk cId="2010364610" sldId="284"/>
+            <ac:spMk id="3" creationId="{1D324E05-11C8-6E19-4B8F-15324250E111}"/>
+          </ac:spMkLst>
+        </pc:spChg>
+        <pc:spChg chg="del">
+          <ac:chgData name="Moritz Schlager" userId="faf8158ddec16f45" providerId="Windows Live" clId="Web-{3EDA70AF-CE7E-153D-0352-F0344AE445A7}" dt="2026-01-06T16:20:51.847" v="3"/>
+          <ac:spMkLst>
+            <pc:docMk/>
+            <pc:sldMk cId="2010364610" sldId="284"/>
+            <ac:spMk id="4" creationId="{6F1CF0BB-03A4-EBA0-89DB-9F6490ED953E}"/>
+          </ac:spMkLst>
+        </pc:spChg>
+      </pc:sldChg>
+      <pc:sldChg chg="mod modShow">
+        <pc:chgData name="Moritz Schlager" userId="faf8158ddec16f45" providerId="Windows Live" clId="Web-{3EDA70AF-CE7E-153D-0352-F0344AE445A7}" dt="2026-01-06T16:20:34.394" v="0"/>
+        <pc:sldMkLst>
+          <pc:docMk/>
+          <pc:sldMk cId="2400761819" sldId="285"/>
+        </pc:sldMkLst>
+      </pc:sldChg>
+    </pc:docChg>
+  </pc:docChgLst>
+</pc:chgInfo>
 </file>
 
 <file path=ppt/slideLayouts/slideLayout1.xml><?xml version="1.0" encoding="utf-8"?>
@@ -262,7 +379,7 @@
           <a:p>
             <a:fld id="{8C90509D-92FA-4939-A039-A3479FC21D0B}" type="datetimeFigureOut">
               <a:rPr lang="de-DE" smtClean="0"/>
-              <a:t>15.01.2025</a:t>
+              <a:t>06.01.2026</a:t>
             </a:fld>
             <a:endParaRPr lang="de-DE"/>
           </a:p>
@@ -316,7 +433,7 @@
           <a:p>
             <a:fld id="{49BBBD81-C55C-424B-A944-5C8BA9DA261A}" type="slidenum">
               <a:rPr lang="de-DE" smtClean="0"/>
-              <a:t>‹Nr.›</a:t>
+              <a:t>‹#›</a:t>
             </a:fld>
             <a:endParaRPr lang="de-DE"/>
           </a:p>
@@ -460,7 +577,7 @@
           <a:p>
             <a:fld id="{8C90509D-92FA-4939-A039-A3479FC21D0B}" type="datetimeFigureOut">
               <a:rPr lang="de-DE" smtClean="0"/>
-              <a:t>15.01.2025</a:t>
+              <a:t>06.01.2026</a:t>
             </a:fld>
             <a:endParaRPr lang="de-DE"/>
           </a:p>
@@ -514,7 +631,7 @@
           <a:p>
             <a:fld id="{49BBBD81-C55C-424B-A944-5C8BA9DA261A}" type="slidenum">
               <a:rPr lang="de-DE" smtClean="0"/>
-              <a:t>‹Nr.›</a:t>
+              <a:t>‹#›</a:t>
             </a:fld>
             <a:endParaRPr lang="de-DE"/>
           </a:p>
@@ -668,7 +785,7 @@
           <a:p>
             <a:fld id="{8C90509D-92FA-4939-A039-A3479FC21D0B}" type="datetimeFigureOut">
               <a:rPr lang="de-DE" smtClean="0"/>
-              <a:t>15.01.2025</a:t>
+              <a:t>06.01.2026</a:t>
             </a:fld>
             <a:endParaRPr lang="de-DE"/>
           </a:p>
@@ -722,7 +839,7 @@
           <a:p>
             <a:fld id="{49BBBD81-C55C-424B-A944-5C8BA9DA261A}" type="slidenum">
               <a:rPr lang="de-DE" smtClean="0"/>
-              <a:t>‹Nr.›</a:t>
+              <a:t>‹#›</a:t>
             </a:fld>
             <a:endParaRPr lang="de-DE"/>
           </a:p>
@@ -866,7 +983,7 @@
           <a:p>
             <a:fld id="{8C90509D-92FA-4939-A039-A3479FC21D0B}" type="datetimeFigureOut">
               <a:rPr lang="de-DE" smtClean="0"/>
-              <a:t>15.01.2025</a:t>
+              <a:t>06.01.2026</a:t>
             </a:fld>
             <a:endParaRPr lang="de-DE"/>
           </a:p>
@@ -920,7 +1037,7 @@
           <a:p>
             <a:fld id="{49BBBD81-C55C-424B-A944-5C8BA9DA261A}" type="slidenum">
               <a:rPr lang="de-DE" smtClean="0"/>
-              <a:t>‹Nr.›</a:t>
+              <a:t>‹#›</a:t>
             </a:fld>
             <a:endParaRPr lang="de-DE"/>
           </a:p>
@@ -1141,7 +1258,7 @@
           <a:p>
             <a:fld id="{8C90509D-92FA-4939-A039-A3479FC21D0B}" type="datetimeFigureOut">
               <a:rPr lang="de-DE" smtClean="0"/>
-              <a:t>15.01.2025</a:t>
+              <a:t>06.01.2026</a:t>
             </a:fld>
             <a:endParaRPr lang="de-DE"/>
           </a:p>
@@ -1195,7 +1312,7 @@
           <a:p>
             <a:fld id="{49BBBD81-C55C-424B-A944-5C8BA9DA261A}" type="slidenum">
               <a:rPr lang="de-DE" smtClean="0"/>
-              <a:t>‹Nr.›</a:t>
+              <a:t>‹#›</a:t>
             </a:fld>
             <a:endParaRPr lang="de-DE"/>
           </a:p>
@@ -1406,7 +1523,7 @@
           <a:p>
             <a:fld id="{8C90509D-92FA-4939-A039-A3479FC21D0B}" type="datetimeFigureOut">
               <a:rPr lang="de-DE" smtClean="0"/>
-              <a:t>15.01.2025</a:t>
+              <a:t>06.01.2026</a:t>
             </a:fld>
             <a:endParaRPr lang="de-DE"/>
           </a:p>
@@ -1460,7 +1577,7 @@
           <a:p>
             <a:fld id="{49BBBD81-C55C-424B-A944-5C8BA9DA261A}" type="slidenum">
               <a:rPr lang="de-DE" smtClean="0"/>
-              <a:t>‹Nr.›</a:t>
+              <a:t>‹#›</a:t>
             </a:fld>
             <a:endParaRPr lang="de-DE"/>
           </a:p>
@@ -1818,7 +1935,7 @@
           <a:p>
             <a:fld id="{8C90509D-92FA-4939-A039-A3479FC21D0B}" type="datetimeFigureOut">
               <a:rPr lang="de-DE" smtClean="0"/>
-              <a:t>15.01.2025</a:t>
+              <a:t>06.01.2026</a:t>
             </a:fld>
             <a:endParaRPr lang="de-DE"/>
           </a:p>
@@ -1872,7 +1989,7 @@
           <a:p>
             <a:fld id="{49BBBD81-C55C-424B-A944-5C8BA9DA261A}" type="slidenum">
               <a:rPr lang="de-DE" smtClean="0"/>
-              <a:t>‹Nr.›</a:t>
+              <a:t>‹#›</a:t>
             </a:fld>
             <a:endParaRPr lang="de-DE"/>
           </a:p>
@@ -1959,7 +2076,7 @@
           <a:p>
             <a:fld id="{8C90509D-92FA-4939-A039-A3479FC21D0B}" type="datetimeFigureOut">
               <a:rPr lang="de-DE" smtClean="0"/>
-              <a:t>15.01.2025</a:t>
+              <a:t>06.01.2026</a:t>
             </a:fld>
             <a:endParaRPr lang="de-DE"/>
           </a:p>
@@ -2013,7 +2130,7 @@
           <a:p>
             <a:fld id="{49BBBD81-C55C-424B-A944-5C8BA9DA261A}" type="slidenum">
               <a:rPr lang="de-DE" smtClean="0"/>
-              <a:t>‹Nr.›</a:t>
+              <a:t>‹#›</a:t>
             </a:fld>
             <a:endParaRPr lang="de-DE"/>
           </a:p>
@@ -2072,7 +2189,7 @@
           <a:p>
             <a:fld id="{8C90509D-92FA-4939-A039-A3479FC21D0B}" type="datetimeFigureOut">
               <a:rPr lang="de-DE" smtClean="0"/>
-              <a:t>15.01.2025</a:t>
+              <a:t>06.01.2026</a:t>
             </a:fld>
             <a:endParaRPr lang="de-DE"/>
           </a:p>
@@ -2126,7 +2243,7 @@
           <a:p>
             <a:fld id="{49BBBD81-C55C-424B-A944-5C8BA9DA261A}" type="slidenum">
               <a:rPr lang="de-DE" smtClean="0"/>
-              <a:t>‹Nr.›</a:t>
+              <a:t>‹#›</a:t>
             </a:fld>
             <a:endParaRPr lang="de-DE"/>
           </a:p>
@@ -2383,7 +2500,7 @@
           <a:p>
             <a:fld id="{8C90509D-92FA-4939-A039-A3479FC21D0B}" type="datetimeFigureOut">
               <a:rPr lang="de-DE" smtClean="0"/>
-              <a:t>15.01.2025</a:t>
+              <a:t>06.01.2026</a:t>
             </a:fld>
             <a:endParaRPr lang="de-DE"/>
           </a:p>
@@ -2437,7 +2554,7 @@
           <a:p>
             <a:fld id="{49BBBD81-C55C-424B-A944-5C8BA9DA261A}" type="slidenum">
               <a:rPr lang="de-DE" smtClean="0"/>
-              <a:t>‹Nr.›</a:t>
+              <a:t>‹#›</a:t>
             </a:fld>
             <a:endParaRPr lang="de-DE"/>
           </a:p>
@@ -2671,7 +2788,7 @@
           <a:p>
             <a:fld id="{8C90509D-92FA-4939-A039-A3479FC21D0B}" type="datetimeFigureOut">
               <a:rPr lang="de-DE" smtClean="0"/>
-              <a:t>15.01.2025</a:t>
+              <a:t>06.01.2026</a:t>
             </a:fld>
             <a:endParaRPr lang="de-DE"/>
           </a:p>
@@ -2725,7 +2842,7 @@
           <a:p>
             <a:fld id="{49BBBD81-C55C-424B-A944-5C8BA9DA261A}" type="slidenum">
               <a:rPr lang="de-DE" smtClean="0"/>
-              <a:t>‹Nr.›</a:t>
+              <a:t>‹#›</a:t>
             </a:fld>
             <a:endParaRPr lang="de-DE"/>
           </a:p>
@@ -2912,7 +3029,7 @@
           <a:p>
             <a:fld id="{8C90509D-92FA-4939-A039-A3479FC21D0B}" type="datetimeFigureOut">
               <a:rPr lang="de-DE" smtClean="0"/>
-              <a:t>15.01.2025</a:t>
+              <a:t>06.01.2026</a:t>
             </a:fld>
             <a:endParaRPr lang="de-DE"/>
           </a:p>
@@ -3002,7 +3119,7 @@
           <a:p>
             <a:fld id="{49BBBD81-C55C-424B-A944-5C8BA9DA261A}" type="slidenum">
               <a:rPr lang="de-DE" smtClean="0"/>
-              <a:t>‹Nr.›</a:t>
+              <a:t>‹#›</a:t>
             </a:fld>
             <a:endParaRPr lang="de-DE"/>
           </a:p>
@@ -3373,7 +3490,7 @@
           <a:p>
             <a:pPr algn="l"/>
             <a:r>
-              <a:rPr kumimoji="0" lang="de-DE" sz="5400" i="0" u="none" strike="noStrike" kern="1200" cap="none" spc="0" normalizeH="0" baseline="0" noProof="0" dirty="0">
+              <a:rPr kumimoji="0" lang="de-DE" sz="4800" i="0" u="none" strike="noStrike" kern="1200" cap="none" spc="0" normalizeH="0" baseline="0" noProof="0">
                 <a:ln>
                   <a:noFill/>
                 </a:ln>
@@ -3389,7 +3506,11 @@
               </a:rPr>
               <a:t>Siegerehrung</a:t>
             </a:r>
-            <a:endParaRPr lang="en-US" sz="5400" dirty="0"/>
+            <a:endParaRPr lang="en-US" sz="4800">
+              <a:solidFill>
+                <a:prstClr val="white"/>
+              </a:solidFill>
+            </a:endParaRPr>
           </a:p>
         </p:txBody>
       </p:sp>
@@ -3416,7 +3537,7 @@
           </a:xfrm>
         </p:spPr>
         <p:txBody>
-          <a:bodyPr>
+          <a:bodyPr vert="horz" lIns="91440" tIns="45720" rIns="91440" bIns="45720" rtlCol="0" anchor="t">
             <a:normAutofit/>
           </a:bodyPr>
           <a:lstStyle/>
@@ -3439,7 +3560,7 @@
               <a:defRPr/>
             </a:pPr>
             <a:r>
-              <a:rPr kumimoji="0" lang="de-DE" i="0" u="none" strike="noStrike" kern="1200" cap="none" spc="0" normalizeH="0" baseline="0" noProof="0" dirty="0" err="1">
+              <a:rPr kumimoji="0" lang="de-DE" i="0" u="none" strike="noStrike" kern="1200" cap="none" spc="0" normalizeH="0" baseline="0" noProof="0" err="1">
                 <a:ln>
                   <a:noFill/>
                 </a:ln>
@@ -3456,7 +3577,7 @@
               <a:t>Budeturnier</a:t>
             </a:r>
             <a:r>
-              <a:rPr kumimoji="0" lang="de-DE" i="0" u="none" strike="noStrike" kern="1200" cap="none" spc="0" normalizeH="0" baseline="0" noProof="0" dirty="0">
+              <a:rPr kumimoji="0" lang="de-DE" i="0" u="none" strike="noStrike" kern="1200" cap="none" spc="0" normalizeH="0" baseline="0" noProof="0">
                 <a:ln>
                   <a:noFill/>
                 </a:ln>
@@ -3470,9 +3591,18 @@
                 <a:ea typeface="+mn-ea"/>
                 <a:cs typeface="+mn-cs"/>
               </a:rPr>
-              <a:t> 2025</a:t>
-            </a:r>
-            <a:endParaRPr kumimoji="0" lang="en-US" i="0" u="none" strike="noStrike" kern="1200" cap="none" spc="0" normalizeH="0" baseline="0" noProof="0" dirty="0">
+              <a:t> </a:t>
+            </a:r>
+            <a:r>
+              <a:rPr lang="de-DE">
+                <a:solidFill>
+                  <a:prstClr val="white"/>
+                </a:solidFill>
+                <a:latin typeface="Calibri" panose="020F0502020204030204"/>
+              </a:rPr>
+              <a:t>2026</a:t>
+            </a:r>
+            <a:endParaRPr kumimoji="0" lang="en-US" i="0" u="none" strike="noStrike" kern="1200" cap="none" spc="0" normalizeH="0" baseline="0" noProof="0">
               <a:ln>
                 <a:noFill/>
               </a:ln>
@@ -3669,7 +3799,7 @@
           <a:lstStyle/>
           <a:p>
             <a:r>
-              <a:rPr lang="de-DE" sz="4000" b="1" dirty="0">
+              <a:rPr lang="de-DE" sz="4000" b="1">
                 <a:latin typeface="Posterama" panose="020B0504020200020000" pitchFamily="34" charset="0"/>
                 <a:cs typeface="Arial" panose="020B0604020202020204" pitchFamily="34" charset="0"/>
               </a:rPr>
@@ -3696,117 +3826,125 @@
         </p:nvSpPr>
         <p:spPr>
           <a:xfrm>
-            <a:off x="838200" y="2684940"/>
-            <a:ext cx="10515600" cy="3831537"/>
+            <a:off x="838200" y="2984297"/>
+            <a:ext cx="10515600" cy="3532180"/>
           </a:xfrm>
         </p:spPr>
         <p:txBody>
-          <a:bodyPr/>
+          <a:bodyPr vert="horz" lIns="91440" tIns="45720" rIns="91440" bIns="45720" rtlCol="0" anchor="t">
+            <a:normAutofit/>
+          </a:bodyPr>
           <a:lstStyle/>
           <a:p>
             <a:r>
-              <a:rPr lang="de-DE" dirty="0"/>
+              <a:rPr lang="de-DE">
+                <a:ea typeface="Calibri"/>
+                <a:cs typeface="Calibri"/>
+              </a:rPr>
+              <a:t>SV Sulmetingen (Equipment)</a:t>
+            </a:r>
+          </a:p>
+          <a:p>
+            <a:r>
+              <a:rPr lang="de-DE">
+                <a:ea typeface="Calibri"/>
+                <a:cs typeface="Calibri"/>
+              </a:rPr>
+              <a:t>Schiedsrichter</a:t>
+            </a:r>
+          </a:p>
+          <a:p>
+            <a:r>
+              <a:rPr lang="de-DE"/>
               <a:t>Marc </a:t>
             </a:r>
             <a:r>
-              <a:rPr lang="de-DE" dirty="0" err="1"/>
+              <a:rPr lang="de-DE" err="1"/>
               <a:t>Gretzinger</a:t>
             </a:r>
             <a:r>
-              <a:rPr lang="de-DE" dirty="0"/>
+              <a:rPr lang="de-DE"/>
               <a:t> (Technik)</a:t>
             </a:r>
           </a:p>
           <a:p>
             <a:r>
-              <a:rPr lang="de-DE" dirty="0"/>
-              <a:t>Christoph Böhringer &amp; Florian </a:t>
-            </a:r>
-            <a:r>
-              <a:rPr lang="de-DE" dirty="0" err="1"/>
-              <a:t>Stöferle</a:t>
-            </a:r>
-            <a:r>
-              <a:rPr lang="de-DE" dirty="0"/>
-              <a:t> (Turnierleitung)</a:t>
-            </a:r>
-          </a:p>
-          <a:p>
-            <a:r>
-              <a:rPr lang="de-DE" dirty="0"/>
-              <a:t>Florian Betz (Turnierplan &amp; Webanwendung</a:t>
-            </a:r>
-          </a:p>
-          <a:p>
-            <a:r>
-              <a:rPr lang="de-DE" dirty="0"/>
-              <a:t>Die ganze </a:t>
-            </a:r>
-            <a:r>
-              <a:rPr lang="de-DE" dirty="0" err="1"/>
-              <a:t>Feschdus</a:t>
-            </a:r>
-            <a:r>
-              <a:rPr lang="de-DE" dirty="0"/>
-              <a:t> Bud</a:t>
-            </a:r>
-            <a:r>
-              <a:rPr lang="en-US" dirty="0"/>
-              <a:t>e</a:t>
-            </a:r>
-          </a:p>
-          <a:p>
-            <a:r>
-              <a:rPr lang="en-US" dirty="0"/>
+              <a:rPr lang="en-US" err="1"/>
+              <a:t>Unsere</a:t>
+            </a:r>
+            <a:r>
+              <a:rPr lang="en-US"/>
+              <a:t> </a:t>
+            </a:r>
+            <a:r>
+              <a:rPr lang="en-US" err="1"/>
+              <a:t>Mädels</a:t>
+            </a:r>
+            <a:r>
+              <a:rPr lang="en-US"/>
+              <a:t> (</a:t>
+            </a:r>
+            <a:r>
+              <a:rPr lang="en-US" err="1"/>
+              <a:t>Küche</a:t>
+            </a:r>
+            <a:r>
+              <a:rPr lang="en-US"/>
+              <a:t> &amp; Bar) </a:t>
+            </a:r>
+            <a:endParaRPr lang="en-US">
+              <a:ea typeface="Calibri"/>
+              <a:cs typeface="Calibri"/>
+            </a:endParaRPr>
+          </a:p>
+          <a:p>
+            <a:r>
+              <a:rPr lang="en-US">
+                <a:ea typeface="Calibri"/>
+                <a:cs typeface="Calibri"/>
+              </a:rPr>
               <a:t>Alle </a:t>
             </a:r>
             <a:r>
-              <a:rPr lang="en-US" dirty="0" err="1"/>
-              <a:t>fleißigen</a:t>
-            </a:r>
-            <a:r>
-              <a:rPr lang="en-US" dirty="0"/>
-              <a:t> Helfer an der Bar</a:t>
-            </a:r>
-          </a:p>
-          <a:p>
-            <a:endParaRPr lang="en-US" dirty="0"/>
+              <a:rPr lang="en-US" err="1">
+                <a:ea typeface="Calibri" panose="020F0502020204030204"/>
+                <a:cs typeface="Calibri" panose="020F0502020204030204"/>
+              </a:rPr>
+              <a:t>Zuschauer</a:t>
+            </a:r>
+            <a:r>
+              <a:rPr lang="en-US">
+                <a:ea typeface="Calibri" panose="020F0502020204030204"/>
+                <a:cs typeface="Calibri" panose="020F0502020204030204"/>
+              </a:rPr>
+              <a:t> &amp; Fans für die </a:t>
+            </a:r>
+            <a:r>
+              <a:rPr lang="en-US" err="1">
+                <a:ea typeface="Calibri" panose="020F0502020204030204"/>
+                <a:cs typeface="Calibri" panose="020F0502020204030204"/>
+              </a:rPr>
+              <a:t>tolle</a:t>
+            </a:r>
+            <a:r>
+              <a:rPr lang="en-US">
+                <a:ea typeface="Calibri" panose="020F0502020204030204"/>
+                <a:cs typeface="Calibri" panose="020F0502020204030204"/>
+              </a:rPr>
+              <a:t> Stimmung</a:t>
+            </a:r>
           </a:p>
           <a:p>
             <a:pPr marL="0" indent="0">
               <a:buNone/>
             </a:pPr>
-            <a:r>
-              <a:rPr lang="en-US" dirty="0"/>
-              <a:t>…und </a:t>
-            </a:r>
-            <a:r>
-              <a:rPr lang="en-US" dirty="0" err="1"/>
-              <a:t>natürlich</a:t>
-            </a:r>
-            <a:r>
-              <a:rPr lang="en-US" dirty="0"/>
-              <a:t> </a:t>
-            </a:r>
-            <a:r>
-              <a:rPr lang="en-US" dirty="0" err="1"/>
-              <a:t>unsere</a:t>
-            </a:r>
-            <a:r>
-              <a:rPr lang="en-US" dirty="0"/>
-              <a:t> </a:t>
-            </a:r>
-            <a:r>
-              <a:rPr lang="en-US" b="1" dirty="0" err="1"/>
-              <a:t>Mädels</a:t>
-            </a:r>
-            <a:r>
-              <a:rPr lang="en-US" b="1" dirty="0"/>
-              <a:t> &lt;3</a:t>
-            </a:r>
-          </a:p>
-          <a:p>
-            <a:endParaRPr lang="de-DE" dirty="0"/>
+            <a:endParaRPr lang="en-US">
+              <a:ea typeface="Calibri" panose="020F0502020204030204"/>
+              <a:cs typeface="Calibri" panose="020F0502020204030204"/>
+            </a:endParaRPr>
+          </a:p>
+          <a:p>
+            <a:endParaRPr lang="de-DE"/>
           </a:p>
         </p:txBody>
       </p:sp>
@@ -5013,50 +5151,6 @@
           </p:txBody>
         </p:sp>
       </p:grpSp>
-      <p:sp>
-        <p:nvSpPr>
-          <p:cNvPr id="4" name="Textfeld 3">
-            <a:extLst>
-              <a:ext uri="{FF2B5EF4-FFF2-40B4-BE49-F238E27FC236}">
-                <a16:creationId xmlns:a16="http://schemas.microsoft.com/office/drawing/2014/main" id="{6F1CF0BB-03A4-EBA0-89DB-9F6490ED953E}"/>
-              </a:ext>
-            </a:extLst>
-          </p:cNvPr>
-          <p:cNvSpPr txBox="1"/>
-          <p:nvPr/>
-        </p:nvSpPr>
-        <p:spPr>
-          <a:xfrm rot="1889802">
-            <a:off x="3040373" y="2902872"/>
-            <a:ext cx="5799986" cy="1569660"/>
-          </a:xfrm>
-          <a:prstGeom prst="rect">
-            <a:avLst/>
-          </a:prstGeom>
-          <a:noFill/>
-        </p:spPr>
-        <p:txBody>
-          <a:bodyPr wrap="none" rtlCol="0">
-            <a:spAutoFit/>
-          </a:bodyPr>
-          <a:lstStyle/>
-          <a:p>
-            <a:r>
-              <a:rPr lang="de-DE" sz="9600" b="1" dirty="0">
-                <a:ln>
-                  <a:solidFill>
-                    <a:schemeClr val="tx1"/>
-                  </a:solidFill>
-                </a:ln>
-                <a:solidFill>
-                  <a:srgbClr val="FF0000"/>
-                </a:solidFill>
-              </a:rPr>
-              <a:t>Anpassen !</a:t>
-            </a:r>
-          </a:p>
-        </p:txBody>
-      </p:sp>
     </p:spTree>
     <p:extLst>
       <p:ext uri="{BB962C8B-B14F-4D97-AF65-F5344CB8AC3E}">
@@ -5109,10 +5203,10 @@
           <a:lstStyle/>
           <a:p>
             <a:r>
-              <a:rPr lang="de-DE" dirty="0"/>
+              <a:rPr lang="de-DE"/>
               <a:t>Dankeschön an unsere Sponsoren</a:t>
             </a:r>
-            <a:endParaRPr lang="en-US" dirty="0"/>
+            <a:endParaRPr lang="en-US"/>
           </a:p>
         </p:txBody>
       </p:sp>
@@ -5189,10 +5283,10 @@
       </p:pic>
       <p:pic>
         <p:nvPicPr>
-          <p:cNvPr id="1026" name="Picture 2">
-            <a:extLst>
-              <a:ext uri="{FF2B5EF4-FFF2-40B4-BE49-F238E27FC236}">
-                <a16:creationId xmlns:a16="http://schemas.microsoft.com/office/drawing/2014/main" id="{2212697B-EE35-E0C4-2BC4-4B59A5C82E4A}"/>
+          <p:cNvPr id="1028" name="Picture 4" descr="Startseite - Schlager Stuckateur">
+            <a:extLst>
+              <a:ext uri="{FF2B5EF4-FFF2-40B4-BE49-F238E27FC236}">
+                <a16:creationId xmlns:a16="http://schemas.microsoft.com/office/drawing/2014/main" id="{409AAE90-B682-E394-46E6-6455321C0991}"/>
               </a:ext>
             </a:extLst>
           </p:cNvPr>
@@ -5203,53 +5297,6 @@
         </p:nvPicPr>
         <p:blipFill>
           <a:blip r:embed="rId4">
-            <a:extLst>
-              <a:ext uri="{28A0092B-C50C-407E-A947-70E740481C1C}">
-                <a14:useLocalDpi xmlns:a14="http://schemas.microsoft.com/office/drawing/2010/main" val="0"/>
-              </a:ext>
-            </a:extLst>
-          </a:blip>
-          <a:srcRect/>
-          <a:stretch>
-            <a:fillRect/>
-          </a:stretch>
-        </p:blipFill>
-        <p:spPr bwMode="auto">
-          <a:xfrm>
-            <a:off x="5369326" y="4826179"/>
-            <a:ext cx="2171700" cy="981075"/>
-          </a:xfrm>
-          <a:prstGeom prst="rect">
-            <a:avLst/>
-          </a:prstGeom>
-          <a:noFill/>
-          <a:extLst>
-            <a:ext uri="{909E8E84-426E-40DD-AFC4-6F175D3DCCD1}">
-              <a14:hiddenFill xmlns:a14="http://schemas.microsoft.com/office/drawing/2010/main">
-                <a:solidFill>
-                  <a:srgbClr val="FFFFFF"/>
-                </a:solidFill>
-              </a14:hiddenFill>
-            </a:ext>
-          </a:extLst>
-        </p:spPr>
-      </p:pic>
-      <p:pic>
-        <p:nvPicPr>
-          <p:cNvPr id="1028" name="Picture 4" descr="Startseite - Schlager Stuckateur">
-            <a:extLst>
-              <a:ext uri="{FF2B5EF4-FFF2-40B4-BE49-F238E27FC236}">
-                <a16:creationId xmlns:a16="http://schemas.microsoft.com/office/drawing/2014/main" id="{409AAE90-B682-E394-46E6-6455321C0991}"/>
-              </a:ext>
-            </a:extLst>
-          </p:cNvPr>
-          <p:cNvPicPr>
-            <a:picLocks noChangeAspect="1" noChangeArrowheads="1"/>
-          </p:cNvPicPr>
-          <p:nvPr/>
-        </p:nvPicPr>
-        <p:blipFill>
-          <a:blip r:embed="rId5">
             <a:extLst>
               <a:ext uri="{28A0092B-C50C-407E-A947-70E740481C1C}">
                 <a14:useLocalDpi xmlns:a14="http://schemas.microsoft.com/office/drawing/2010/main" val="0"/>
@@ -5296,7 +5343,7 @@
           <p:nvPr/>
         </p:nvPicPr>
         <p:blipFill>
-          <a:blip r:embed="rId6">
+          <a:blip r:embed="rId5">
             <a:extLst>
               <a:ext uri="{28A0092B-C50C-407E-A947-70E740481C1C}">
                 <a14:useLocalDpi xmlns:a14="http://schemas.microsoft.com/office/drawing/2010/main" val="0"/>
@@ -5332,7 +5379,7 @@
           <p:nvPr/>
         </p:nvPicPr>
         <p:blipFill>
-          <a:blip r:embed="rId7">
+          <a:blip r:embed="rId6">
             <a:extLst>
               <a:ext uri="{28A0092B-C50C-407E-A947-70E740481C1C}">
                 <a14:useLocalDpi xmlns:a14="http://schemas.microsoft.com/office/drawing/2010/main" val="0"/>
@@ -5376,24 +5423,30 @@
           <a:noFill/>
         </p:spPr>
         <p:txBody>
-          <a:bodyPr wrap="none" rtlCol="0">
+          <a:bodyPr wrap="none" lIns="91440" tIns="45720" rIns="91440" bIns="45720" rtlCol="0" anchor="t">
             <a:spAutoFit/>
           </a:bodyPr>
           <a:lstStyle/>
           <a:p>
             <a:r>
-              <a:rPr lang="de-DE" sz="9600" b="1" dirty="0">
+              <a:rPr lang="de-DE" sz="9600" b="1">
                 <a:ln>
                   <a:solidFill>
                     <a:schemeClr val="tx1"/>
                   </a:solidFill>
                 </a:ln>
-                <a:solidFill>
-                  <a:srgbClr val="FF0000"/>
-                </a:solidFill>
               </a:rPr>
               <a:t>Anpassen !</a:t>
             </a:r>
+            <a:endParaRPr lang="de-DE" sz="9600" b="1">
+              <a:ln>
+                <a:solidFill>
+                  <a:prstClr val="black"/>
+                </a:solidFill>
+              </a:ln>
+              <a:ea typeface="Calibri"/>
+              <a:cs typeface="Calibri"/>
+            </a:endParaRPr>
           </a:p>
         </p:txBody>
       </p:sp>
@@ -5412,7 +5465,7 @@
           <p:nvPr/>
         </p:nvPicPr>
         <p:blipFill>
-          <a:blip r:embed="rId8">
+          <a:blip r:embed="rId7">
             <a:extLst>
               <a:ext uri="{28A0092B-C50C-407E-A947-70E740481C1C}">
                 <a14:useLocalDpi xmlns:a14="http://schemas.microsoft.com/office/drawing/2010/main" val="0"/>
@@ -6725,13 +6778,13 @@
               </a:spcAft>
             </a:pPr>
             <a:r>
-              <a:rPr lang="de-DE" sz="4000" b="1" dirty="0">
+              <a:rPr lang="de-DE" sz="4000" b="1">
                 <a:latin typeface="Posterama" panose="020B0504020200020000" pitchFamily="34" charset="0"/>
                 <a:cs typeface="Arial" panose="020B0604020202020204" pitchFamily="34" charset="0"/>
               </a:rPr>
               <a:t>NAME – Diese Folie ausblenden</a:t>
             </a:r>
-            <a:endParaRPr lang="en-US" sz="4000" b="1" dirty="0">
+            <a:endParaRPr lang="en-US" sz="4000" b="1">
               <a:latin typeface="Posterama" panose="020B0504020200020000" pitchFamily="34" charset="0"/>
               <a:cs typeface="Arial" panose="020B0604020202020204" pitchFamily="34" charset="0"/>
             </a:endParaRPr>
@@ -6783,7 +6836,7 @@
               </a:spcAft>
             </a:pPr>
             <a:r>
-              <a:rPr lang="en-US" sz="4800" b="1" dirty="0">
+              <a:rPr lang="en-US" sz="4800" b="1">
                 <a:effectLst/>
                 <a:latin typeface="Calibri" panose="020F0502020204030204" pitchFamily="34" charset="0"/>
                 <a:ea typeface="Calibri" panose="020F0502020204030204" pitchFamily="34" charset="0"/>
@@ -6792,7 +6845,7 @@
               <a:t>15</a:t>
             </a:r>
             <a:r>
-              <a:rPr lang="en-US" sz="2800" b="1" dirty="0">
+              <a:rPr lang="en-US" sz="2800" b="1">
                 <a:effectLst/>
                 <a:latin typeface="Calibri" panose="020F0502020204030204" pitchFamily="34" charset="0"/>
                 <a:ea typeface="Calibri" panose="020F0502020204030204" pitchFamily="34" charset="0"/>
@@ -6800,7 +6853,7 @@
               </a:rPr>
               <a:t>.</a:t>
             </a:r>
-            <a:endParaRPr lang="en-US" sz="1100" dirty="0">
+            <a:endParaRPr lang="en-US" sz="1100">
               <a:effectLst/>
               <a:latin typeface="Calibri" panose="020F0502020204030204" pitchFamily="34" charset="0"/>
               <a:ea typeface="Calibri" panose="020F0502020204030204" pitchFamily="34" charset="0"/>
@@ -6854,7 +6907,7 @@
               </a:spcAft>
             </a:pPr>
             <a:r>
-              <a:rPr lang="en-US" sz="1800" dirty="0">
+              <a:rPr lang="en-US" sz="1800">
                 <a:effectLst/>
                 <a:latin typeface="Calibri" panose="020F0502020204030204" pitchFamily="34" charset="0"/>
                 <a:ea typeface="Calibri" panose="020F0502020204030204" pitchFamily="34" charset="0"/>
@@ -6862,7 +6915,7 @@
               </a:rPr>
               <a:t>Platz</a:t>
             </a:r>
-            <a:endParaRPr lang="en-US" sz="1100" dirty="0">
+            <a:endParaRPr lang="en-US" sz="1100">
               <a:effectLst/>
               <a:latin typeface="Calibri" panose="020F0502020204030204" pitchFamily="34" charset="0"/>
               <a:ea typeface="Calibri" panose="020F0502020204030204" pitchFamily="34" charset="0"/>

</xml_diff>